<commit_message>
Give udhaar its own QR, and let several people wait at the counter
A separate udhaar QR beside the pay QR, so a customer who is only paying
never sees udhaar. Scanning it just says "I'm at the counter".

The shopkeeper's screen lists everyone who scanned in the last three
minutes, oldest first, with the first already picked. He taps another
or says the name first, which only has to match the people standing
there. A wrong pick is caught when that customer declines.

Adding someone who can't scan asks only for a number or UPI ID: we know
nothing else about a new customer.
</commit_message>
<xml_diff>
--- a/docs/BAHI-Round1.pptx
+++ b/docs/BAHI-Round1.pptx
@@ -3239,7 +3239,7 @@
                 </a:solidFill>
                 <a:latin typeface="Arial"/>
               </a:rPr>
-              <a:t>The customer scans the shop’s Paytm QR and chooses udhaar. The shopkeeper says the amount to his Soundbox, and the customer confirms it on his own phone. Every night, an agent decides who actually needs a reminder.</a:t>
+              <a:t>The customer scans the shop’s udhaar QR at the counter. The shopkeeper says the amount to his Soundbox, and the customer confirms it on his own phone. Every night, an agent decides who actually needs a reminder.</a:t>
             </a:r>
           </a:p>
         </p:txBody>
@@ -5599,7 +5599,7 @@
                 </a:solidFill>
                 <a:latin typeface="Arial"/>
               </a:rPr>
-              <a:t>The shop’s Paytm QR. He taps “Take on udhaar”.</a:t>
+              <a:t>A separate udhaar QR, so paying customers never see it.</a:t>
             </a:r>
           </a:p>
         </p:txBody>
@@ -14274,7 +14274,7 @@
                 </a:solidFill>
                 <a:latin typeface="Arial"/>
               </a:rPr>
-              <a:t>A judge scans our QR and taps Udhaar.</a:t>
+              <a:t>A judge scans our udhaar QR.</a:t>
             </a:r>
           </a:p>
         </p:txBody>
@@ -14959,7 +14959,7 @@
                 </a:solidFill>
                 <a:latin typeface="Arial"/>
               </a:rPr>
-              <a:t>Speech mishears the amount</a:t>
+              <a:t>Wrong amount, or wrong person</a:t>
             </a:r>
           </a:p>
         </p:txBody>
@@ -15004,7 +15004,7 @@
                 </a:solidFill>
                 <a:latin typeface="Arial"/>
               </a:rPr>
-              <a:t>The amount is shown before sending; “Say it again” is one tap. No model ever writes the number.</a:t>
+              <a:t>Both are shown before sending, and the customer must confirm, so a mistake is never silent.</a:t>
             </a:r>
           </a:p>
         </p:txBody>

</xml_diff>

<commit_message>
Add the scan-at-the-till flow to the screens and the deck
The customer scans the shop's Paytm QR and chooses udhaar, so the scan
says who and the shopkeeper only says the amount. The Soundbox chimes and
never speaks the customer's name. Customers who can't scan are invited
by number or UPI ID, or kept by name only.

New screens B0 (scan, then choose) and A4 (add someone who can't scan),
A2 reworked for amount-only voice with a type-it fallback, and the rules
section corrected to match the deck. Slide 3 is now five steps starting
with the scan. docs/render_screens.py regenerates every phone image from
screens.html.
</commit_message>
<xml_diff>
--- a/docs/BAHI-Round1.pptx
+++ b/docs/BAHI-Round1.pptx
@@ -3239,7 +3239,7 @@
                 </a:solidFill>
                 <a:latin typeface="Arial"/>
               </a:rPr>
-              <a:t>The shopkeeper speaks a credit entry to his Paytm Soundbox. The customer confirms it on his own phone and pays in one tap. Every night, an agent decides who actually needs a reminder.</a:t>
+              <a:t>The customer scans the shop’s Paytm QR and chooses udhaar. The shopkeeper says the amount to his Soundbox, and the customer confirms it on his own phone. Every night, an agent decides who actually needs a reminder.</a:t>
             </a:r>
           </a:p>
         </p:txBody>
@@ -5441,7 +5441,7 @@
       </p:sp>
       <p:pic>
         <p:nvPicPr>
-          <p:cNvPr id="5" name="Picture 4" descr="A2-speak.png"/>
+          <p:cNvPr id="5" name="Picture 4" descr="B0-scan.png"/>
           <p:cNvPicPr>
             <a:picLocks noChangeAspect="1"/>
           </p:cNvPicPr>
@@ -5455,8 +5455,8 @@
         </p:blipFill>
         <p:spPr>
           <a:xfrm>
-            <a:off x="961605" y="1517904"/>
-            <a:ext cx="1783080" cy="3522670"/>
+            <a:off x="813175" y="1481328"/>
+            <a:ext cx="1572768" cy="3107175"/>
           </a:xfrm>
           <a:prstGeom prst="rect">
             <a:avLst/>
@@ -5471,8 +5471,8 @@
         </p:nvSpPr>
         <p:spPr>
           <a:xfrm>
-            <a:off x="612648" y="5157216"/>
-            <a:ext cx="329184" cy="329184"/>
+            <a:off x="603504" y="4700016"/>
+            <a:ext cx="292608" cy="292608"/>
           </a:xfrm>
           <a:prstGeom prst="ellipse">
             <a:avLst/>
@@ -5500,8 +5500,8 @@
         </p:nvSpPr>
         <p:spPr>
           <a:xfrm>
-            <a:off x="612648" y="5157216"/>
-            <a:ext cx="329184" cy="329184"/>
+            <a:off x="603504" y="4700016"/>
+            <a:ext cx="292608" cy="292608"/>
           </a:xfrm>
           <a:prstGeom prst="rect">
             <a:avLst/>
@@ -5526,7 +5526,7 @@
               </a:spcAft>
             </a:pPr>
             <a:r>
-              <a:rPr sz="1200" b="1">
+              <a:rPr sz="1100" b="1">
                 <a:solidFill>
                   <a:srgbClr val="FFFFFF"/>
                 </a:solidFill>
@@ -5545,8 +5545,8 @@
         </p:nvSpPr>
         <p:spPr>
           <a:xfrm>
-            <a:off x="1042416" y="5175504"/>
-            <a:ext cx="2096947" cy="1097280"/>
+            <a:off x="969264" y="4700016"/>
+            <a:ext cx="1662927" cy="1371600"/>
           </a:xfrm>
           <a:prstGeom prst="rect">
             <a:avLst/>
@@ -5571,13 +5571,13 @@
               </a:spcAft>
             </a:pPr>
             <a:r>
-              <a:rPr sz="1400" b="1">
+              <a:rPr sz="1300" b="1">
                 <a:solidFill>
                   <a:srgbClr val="002970"/>
                 </a:solidFill>
                 <a:latin typeface="Arial"/>
               </a:rPr>
-              <a:t>He speaks it</a:t>
+              <a:t>He scans at the till</a:t>
             </a:r>
           </a:p>
           <a:p>
@@ -5599,14 +5599,14 @@
                 </a:solidFill>
                 <a:latin typeface="Arial"/>
               </a:rPr>
-              <a:t>“Sharma ko do sau udhaar” is shown back to check before it is sent.</a:t>
+              <a:t>The shop’s Paytm QR. He taps “Take on udhaar”.</a:t>
             </a:r>
           </a:p>
         </p:txBody>
       </p:sp>
       <p:pic>
         <p:nvPicPr>
-          <p:cNvPr id="9" name="Picture 8" descr="B1-confirm.png"/>
+          <p:cNvPr id="9" name="Picture 8" descr="A2-speak.png"/>
           <p:cNvPicPr>
             <a:picLocks noChangeAspect="1"/>
           </p:cNvPicPr>
@@ -5620,8 +5620,8 @@
         </p:blipFill>
         <p:spPr>
           <a:xfrm>
-            <a:off x="3790072" y="1517904"/>
-            <a:ext cx="1783080" cy="3522670"/>
+            <a:off x="3061318" y="1481328"/>
+            <a:ext cx="1572768" cy="3107175"/>
           </a:xfrm>
           <a:prstGeom prst="rect">
             <a:avLst/>
@@ -5636,8 +5636,8 @@
         </p:nvSpPr>
         <p:spPr>
           <a:xfrm>
-            <a:off x="3441115" y="5157216"/>
-            <a:ext cx="329184" cy="329184"/>
+            <a:off x="2851647" y="4700016"/>
+            <a:ext cx="292608" cy="292608"/>
           </a:xfrm>
           <a:prstGeom prst="ellipse">
             <a:avLst/>
@@ -5665,8 +5665,8 @@
         </p:nvSpPr>
         <p:spPr>
           <a:xfrm>
-            <a:off x="3441115" y="5157216"/>
-            <a:ext cx="329184" cy="329184"/>
+            <a:off x="2851647" y="4700016"/>
+            <a:ext cx="292608" cy="292608"/>
           </a:xfrm>
           <a:prstGeom prst="rect">
             <a:avLst/>
@@ -5691,7 +5691,7 @@
               </a:spcAft>
             </a:pPr>
             <a:r>
-              <a:rPr sz="1200" b="1">
+              <a:rPr sz="1100" b="1">
                 <a:solidFill>
                   <a:srgbClr val="FFFFFF"/>
                 </a:solidFill>
@@ -5710,8 +5710,8 @@
         </p:nvSpPr>
         <p:spPr>
           <a:xfrm>
-            <a:off x="3870883" y="5175504"/>
-            <a:ext cx="2096947" cy="1097280"/>
+            <a:off x="3217407" y="4700016"/>
+            <a:ext cx="1662927" cy="1371600"/>
           </a:xfrm>
           <a:prstGeom prst="rect">
             <a:avLst/>
@@ -5736,13 +5736,13 @@
               </a:spcAft>
             </a:pPr>
             <a:r>
-              <a:rPr sz="1400" b="1">
+              <a:rPr sz="1300" b="1">
                 <a:solidFill>
                   <a:srgbClr val="002970"/>
                 </a:solidFill>
                 <a:latin typeface="Arial"/>
               </a:rPr>
-              <a:t>The customer confirms</a:t>
+              <a:t>The shopkeeper says the amount</a:t>
             </a:r>
           </a:p>
           <a:p>
@@ -5764,14 +5764,14 @@
                 </a:solidFill>
                 <a:latin typeface="Arial"/>
               </a:rPr>
-              <a:t>He taps “Yes, I owe ₹200” in his own Paytm app.</a:t>
+              <a:t>The scan says who. He says “do sau”, or types it.</a:t>
             </a:r>
           </a:p>
         </p:txBody>
       </p:sp>
       <p:pic>
         <p:nvPicPr>
-          <p:cNvPr id="13" name="Picture 12" descr="B2-mybook.png"/>
+          <p:cNvPr id="13" name="Picture 12" descr="B1-confirm.png"/>
           <p:cNvPicPr>
             <a:picLocks noChangeAspect="1"/>
           </p:cNvPicPr>
@@ -5785,8 +5785,8 @@
         </p:blipFill>
         <p:spPr>
           <a:xfrm>
-            <a:off x="6618539" y="1517904"/>
-            <a:ext cx="1783080" cy="3522670"/>
+            <a:off x="5309461" y="1481328"/>
+            <a:ext cx="1572768" cy="3107175"/>
           </a:xfrm>
           <a:prstGeom prst="rect">
             <a:avLst/>
@@ -5801,8 +5801,8 @@
         </p:nvSpPr>
         <p:spPr>
           <a:xfrm>
-            <a:off x="6269582" y="5157216"/>
-            <a:ext cx="329184" cy="329184"/>
+            <a:off x="5099790" y="4700016"/>
+            <a:ext cx="292608" cy="292608"/>
           </a:xfrm>
           <a:prstGeom prst="ellipse">
             <a:avLst/>
@@ -5830,8 +5830,8 @@
         </p:nvSpPr>
         <p:spPr>
           <a:xfrm>
-            <a:off x="6269582" y="5157216"/>
-            <a:ext cx="329184" cy="329184"/>
+            <a:off x="5099790" y="4700016"/>
+            <a:ext cx="292608" cy="292608"/>
           </a:xfrm>
           <a:prstGeom prst="rect">
             <a:avLst/>
@@ -5856,7 +5856,7 @@
               </a:spcAft>
             </a:pPr>
             <a:r>
-              <a:rPr sz="1200" b="1">
+              <a:rPr sz="1100" b="1">
                 <a:solidFill>
                   <a:srgbClr val="FFFFFF"/>
                 </a:solidFill>
@@ -5875,8 +5875,8 @@
         </p:nvSpPr>
         <p:spPr>
           <a:xfrm>
-            <a:off x="6699350" y="5175504"/>
-            <a:ext cx="2096947" cy="1097280"/>
+            <a:off x="5465550" y="4700016"/>
+            <a:ext cx="1662927" cy="1371600"/>
           </a:xfrm>
           <a:prstGeom prst="rect">
             <a:avLst/>
@@ -5901,13 +5901,13 @@
               </a:spcAft>
             </a:pPr>
             <a:r>
-              <a:rPr sz="1400" b="1">
+              <a:rPr sz="1300" b="1">
                 <a:solidFill>
                   <a:srgbClr val="002970"/>
                 </a:solidFill>
                 <a:latin typeface="Arial"/>
               </a:rPr>
-              <a:t>He sees every shop</a:t>
+              <a:t>Confirmed, right there</a:t>
             </a:r>
           </a:p>
           <a:p>
@@ -5929,14 +5929,14 @@
                 </a:solidFill>
                 <a:latin typeface="Arial"/>
               </a:rPr>
-              <a:t>One total across all his shops, and one tap to pay.</a:t>
+              <a:t>“Yes, I owe ₹200”, on the phone in his hand.</a:t>
             </a:r>
           </a:p>
         </p:txBody>
       </p:sp>
       <p:pic>
         <p:nvPicPr>
-          <p:cNvPr id="17" name="Picture 16" descr="A3-tonight.png"/>
+          <p:cNvPr id="17" name="Picture 16" descr="B2-mybook.png"/>
           <p:cNvPicPr>
             <a:picLocks noChangeAspect="1"/>
           </p:cNvPicPr>
@@ -5950,8 +5950,8 @@
         </p:blipFill>
         <p:spPr>
           <a:xfrm>
-            <a:off x="9447006" y="1517904"/>
-            <a:ext cx="1783080" cy="3522670"/>
+            <a:off x="7557604" y="1481328"/>
+            <a:ext cx="1572768" cy="3107175"/>
           </a:xfrm>
           <a:prstGeom prst="rect">
             <a:avLst/>
@@ -5966,8 +5966,8 @@
         </p:nvSpPr>
         <p:spPr>
           <a:xfrm>
-            <a:off x="9098049" y="5157216"/>
-            <a:ext cx="329184" cy="329184"/>
+            <a:off x="7347933" y="4700016"/>
+            <a:ext cx="292608" cy="292608"/>
           </a:xfrm>
           <a:prstGeom prst="ellipse">
             <a:avLst/>
@@ -5995,8 +5995,8 @@
         </p:nvSpPr>
         <p:spPr>
           <a:xfrm>
-            <a:off x="9098049" y="5157216"/>
-            <a:ext cx="329184" cy="329184"/>
+            <a:off x="7347933" y="4700016"/>
+            <a:ext cx="292608" cy="292608"/>
           </a:xfrm>
           <a:prstGeom prst="rect">
             <a:avLst/>
@@ -6021,7 +6021,7 @@
               </a:spcAft>
             </a:pPr>
             <a:r>
-              <a:rPr sz="1200" b="1">
+              <a:rPr sz="1100" b="1">
                 <a:solidFill>
                   <a:srgbClr val="FFFFFF"/>
                 </a:solidFill>
@@ -6040,8 +6040,8 @@
         </p:nvSpPr>
         <p:spPr>
           <a:xfrm>
-            <a:off x="9527817" y="5175504"/>
-            <a:ext cx="2096947" cy="1097280"/>
+            <a:off x="7713693" y="4700016"/>
+            <a:ext cx="1662927" cy="1371600"/>
           </a:xfrm>
           <a:prstGeom prst="rect">
             <a:avLst/>
@@ -6066,13 +6066,13 @@
               </a:spcAft>
             </a:pPr>
             <a:r>
-              <a:rPr sz="1400" b="1">
+              <a:rPr sz="1300" b="1">
                 <a:solidFill>
                   <a:srgbClr val="002970"/>
                 </a:solidFill>
                 <a:latin typeface="Arial"/>
               </a:rPr>
-              <a:t>The agent picks the day</a:t>
+              <a:t>He sees every shop</a:t>
             </a:r>
           </a:p>
           <a:p>
@@ -6094,21 +6094,119 @@
                 </a:solidFill>
                 <a:latin typeface="Arial"/>
               </a:rPr>
-              <a:t>Sharma always pays on day 9, so on day 4 he hears nothing.</a:t>
-            </a:r>
-          </a:p>
-        </p:txBody>
-      </p:sp>
-      <p:sp>
-        <p:nvSpPr>
-          <p:cNvPr id="21" name="TextBox 20"/>
+              <a:t>One total across his shops, one tap to pay.</a:t>
+            </a:r>
+          </a:p>
+        </p:txBody>
+      </p:sp>
+      <p:pic>
+        <p:nvPicPr>
+          <p:cNvPr id="21" name="Picture 20" descr="A3-tonight.png"/>
+          <p:cNvPicPr>
+            <a:picLocks noChangeAspect="1"/>
+          </p:cNvPicPr>
+          <p:nvPr/>
+        </p:nvPicPr>
+        <p:blipFill>
+          <a:blip r:embed="rId6"/>
+          <a:stretch>
+            <a:fillRect/>
+          </a:stretch>
+        </p:blipFill>
+        <p:spPr>
+          <a:xfrm>
+            <a:off x="9805747" y="1481328"/>
+            <a:ext cx="1572768" cy="3107175"/>
+          </a:xfrm>
+          <a:prstGeom prst="rect">
+            <a:avLst/>
+          </a:prstGeom>
+        </p:spPr>
+      </p:pic>
+      <p:sp>
+        <p:nvSpPr>
+          <p:cNvPr id="22" name="Oval 21"/>
+          <p:cNvSpPr/>
+          <p:nvPr/>
+        </p:nvSpPr>
+        <p:spPr>
+          <a:xfrm>
+            <a:off x="9596076" y="4700016"/>
+            <a:ext cx="292608" cy="292608"/>
+          </a:xfrm>
+          <a:prstGeom prst="ellipse">
+            <a:avLst/>
+          </a:prstGeom>
+          <a:solidFill>
+            <a:srgbClr val="002970"/>
+          </a:solidFill>
+          <a:ln>
+            <a:noFill/>
+          </a:ln>
+        </p:spPr>
+        <p:txBody>
+          <a:bodyPr rtlCol="0" anchor="ctr"/>
+          <a:lstStyle/>
+          <a:p>
+            <a:pPr algn="ctr"/>
+          </a:p>
+        </p:txBody>
+      </p:sp>
+      <p:sp>
+        <p:nvSpPr>
+          <p:cNvPr id="23" name="TextBox 22"/>
           <p:cNvSpPr txBox="1"/>
           <p:nvPr/>
         </p:nvSpPr>
         <p:spPr>
           <a:xfrm>
-            <a:off x="566928" y="6382512"/>
-            <a:ext cx="10326319" cy="274320"/>
+            <a:off x="9596076" y="4700016"/>
+            <a:ext cx="292608" cy="292608"/>
+          </a:xfrm>
+          <a:prstGeom prst="rect">
+            <a:avLst/>
+          </a:prstGeom>
+          <a:noFill/>
+        </p:spPr>
+        <p:txBody>
+          <a:bodyPr wrap="square" lIns="0" rIns="0" tIns="0" bIns="0" anchor="ctr">
+            <a:spAutoFit/>
+          </a:bodyPr>
+          <a:lstStyle/>
+          <a:p>
+            <a:pPr algn="ctr">
+              <a:lnSpc>
+                <a:spcPct val="100000"/>
+              </a:lnSpc>
+              <a:spcBef>
+                <a:spcPts val="0"/>
+              </a:spcBef>
+              <a:spcAft>
+                <a:spcPts val="0"/>
+              </a:spcAft>
+            </a:pPr>
+            <a:r>
+              <a:rPr sz="1100" b="1">
+                <a:solidFill>
+                  <a:srgbClr val="FFFFFF"/>
+                </a:solidFill>
+                <a:latin typeface="Arial"/>
+              </a:rPr>
+              <a:t>5</a:t>
+            </a:r>
+          </a:p>
+        </p:txBody>
+      </p:sp>
+      <p:sp>
+        <p:nvSpPr>
+          <p:cNvPr id="24" name="TextBox 23"/>
+          <p:cNvSpPr txBox="1"/>
+          <p:nvPr/>
+        </p:nvSpPr>
+        <p:spPr>
+          <a:xfrm>
+            <a:off x="9961836" y="4700016"/>
+            <a:ext cx="1662927" cy="1371600"/>
           </a:xfrm>
           <a:prstGeom prst="rect">
             <a:avLst/>
@@ -6123,6 +6221,73 @@
           <a:p>
             <a:pPr>
               <a:lnSpc>
+                <a:spcPct val="110000"/>
+              </a:lnSpc>
+              <a:spcBef>
+                <a:spcPts val="0"/>
+              </a:spcBef>
+              <a:spcAft>
+                <a:spcPts val="0"/>
+              </a:spcAft>
+            </a:pPr>
+            <a:r>
+              <a:rPr sz="1300" b="1">
+                <a:solidFill>
+                  <a:srgbClr val="002970"/>
+                </a:solidFill>
+                <a:latin typeface="Arial"/>
+              </a:rPr>
+              <a:t>The agent picks the day</a:t>
+            </a:r>
+          </a:p>
+          <a:p>
+            <a:pPr>
+              <a:lnSpc>
+                <a:spcPct val="130000"/>
+              </a:lnSpc>
+              <a:spcBef>
+                <a:spcPts val="400"/>
+              </a:spcBef>
+              <a:spcAft>
+                <a:spcPts val="0"/>
+              </a:spcAft>
+            </a:pPr>
+            <a:r>
+              <a:rPr sz="1200" b="0">
+                <a:solidFill>
+                  <a:srgbClr val="5B6675"/>
+                </a:solidFill>
+                <a:latin typeface="Arial"/>
+              </a:rPr>
+              <a:t>Sharma pays on day 9, so on day 4 he hears nothing.</a:t>
+            </a:r>
+          </a:p>
+        </p:txBody>
+      </p:sp>
+      <p:sp>
+        <p:nvSpPr>
+          <p:cNvPr id="25" name="TextBox 24"/>
+          <p:cNvSpPr txBox="1"/>
+          <p:nvPr/>
+        </p:nvSpPr>
+        <p:spPr>
+          <a:xfrm>
+            <a:off x="566928" y="6382512"/>
+            <a:ext cx="10326319" cy="274320"/>
+          </a:xfrm>
+          <a:prstGeom prst="rect">
+            <a:avLst/>
+          </a:prstGeom>
+          <a:noFill/>
+        </p:spPr>
+        <p:txBody>
+          <a:bodyPr wrap="square" lIns="0" rIns="0" tIns="0" bIns="0" anchor="t">
+            <a:spAutoFit/>
+          </a:bodyPr>
+          <a:lstStyle/>
+          <a:p>
+            <a:pPr>
+              <a:lnSpc>
                 <a:spcPct val="120000"/>
               </a:lnSpc>
               <a:spcBef>
@@ -6146,7 +6311,7 @@
       </p:sp>
       <p:sp>
         <p:nvSpPr>
-          <p:cNvPr id="22" name="TextBox 21"/>
+          <p:cNvPr id="26" name="TextBox 25"/>
           <p:cNvSpPr txBox="1"/>
           <p:nvPr/>
         </p:nvSpPr>
@@ -6464,7 +6629,7 @@
                 </a:solidFill>
                 <a:latin typeface="Arial"/>
               </a:rPr>
-              <a:t>to the Soundbox</a:t>
+              <a:t>after the customer scans</a:t>
             </a:r>
           </a:p>
         </p:txBody>
@@ -6758,7 +6923,7 @@
                 </a:solidFill>
                 <a:latin typeface="Arial"/>
               </a:rPr>
-              <a:t>“Sharma ko do sau udhaar”</a:t>
+              <a:t>“do sau”</a:t>
             </a:r>
           </a:p>
           <a:p>
@@ -10235,7 +10400,7 @@
                 </a:solidFill>
                 <a:latin typeface="Arial"/>
               </a:rPr>
-              <a:t>Voice-first</a:t>
+              <a:t>Scan, then speak</a:t>
             </a:r>
           </a:p>
           <a:p>
@@ -10257,7 +10422,7 @@
                 </a:solidFill>
                 <a:latin typeface="Arial"/>
               </a:rPr>
-              <a:t>Spoken to the Soundbox already on the counter. No typing.</a:t>
+              <a:t>The QR says who, his voice says how much. Nothing to type.</a:t>
             </a:r>
           </a:p>
         </p:txBody>
@@ -14109,7 +14274,7 @@
                 </a:solidFill>
                 <a:latin typeface="Arial"/>
               </a:rPr>
-              <a:t>The shopkeeper speaks an entry.</a:t>
+              <a:t>A judge scans our QR and taps Udhaar.</a:t>
             </a:r>
           </a:p>
         </p:txBody>
@@ -14228,7 +14393,7 @@
                 </a:solidFill>
                 <a:latin typeface="Arial"/>
               </a:rPr>
-              <a:t>A judge’s phone buzzes.</a:t>
+              <a:t>The shopkeeper says the amount.</a:t>
             </a:r>
           </a:p>
         </p:txBody>
@@ -14347,7 +14512,7 @@
                 </a:solidFill>
                 <a:latin typeface="Arial"/>
               </a:rPr>
-              <a:t>The judge taps Confirm.</a:t>
+              <a:t>The judge confirms on their own phone.</a:t>
             </a:r>
           </a:p>
         </p:txBody>

</xml_diff>